<commit_message>
si_mucosa alterations in progress
</commit_message>
<xml_diff>
--- a/fragments/overview_fragments.pptx
+++ b/fragments/overview_fragments.pptx
@@ -5,10 +5,11 @@
     <p:sldMasterId id="2147483696" r:id="rId1"/>
   </p:sldMasterIdLst>
   <p:notesMasterIdLst>
-    <p:notesMasterId r:id="rId3"/>
+    <p:notesMasterId r:id="rId4"/>
   </p:notesMasterIdLst>
   <p:sldIdLst>
     <p:sldId id="256" r:id="rId2"/>
+    <p:sldId id="257" r:id="rId3"/>
   </p:sldIdLst>
   <p:sldSz cx="18288000" cy="13716000"/>
   <p:notesSz cx="6858000" cy="9144000"/>
@@ -197,7 +198,7 @@
           <a:p>
             <a:fld id="{572CFEC4-4E45-284D-BF69-DE46D4CD8194}" type="datetimeFigureOut">
               <a:rPr lang="en-US" smtClean="0"/>
-              <a:t>4/24/25</a:t>
+              <a:t>6/6/25</a:t>
             </a:fld>
             <a:endParaRPr lang="en-US"/>
           </a:p>
@@ -684,7 +685,7 @@
           <a:p>
             <a:fld id="{00653A69-F55D-6944-9B3A-CF37B0944481}" type="datetimeFigureOut">
               <a:rPr lang="en-US" smtClean="0"/>
-              <a:t>4/24/25</a:t>
+              <a:t>6/6/25</a:t>
             </a:fld>
             <a:endParaRPr lang="en-US"/>
           </a:p>
@@ -854,7 +855,7 @@
           <a:p>
             <a:fld id="{00653A69-F55D-6944-9B3A-CF37B0944481}" type="datetimeFigureOut">
               <a:rPr lang="en-US" smtClean="0"/>
-              <a:t>4/24/25</a:t>
+              <a:t>6/6/25</a:t>
             </a:fld>
             <a:endParaRPr lang="en-US"/>
           </a:p>
@@ -1034,7 +1035,7 @@
           <a:p>
             <a:fld id="{00653A69-F55D-6944-9B3A-CF37B0944481}" type="datetimeFigureOut">
               <a:rPr lang="en-US" smtClean="0"/>
-              <a:t>4/24/25</a:t>
+              <a:t>6/6/25</a:t>
             </a:fld>
             <a:endParaRPr lang="en-US"/>
           </a:p>
@@ -1204,7 +1205,7 @@
           <a:p>
             <a:fld id="{00653A69-F55D-6944-9B3A-CF37B0944481}" type="datetimeFigureOut">
               <a:rPr lang="en-US" smtClean="0"/>
-              <a:t>4/24/25</a:t>
+              <a:t>6/6/25</a:t>
             </a:fld>
             <a:endParaRPr lang="en-US"/>
           </a:p>
@@ -1450,7 +1451,7 @@
           <a:p>
             <a:fld id="{00653A69-F55D-6944-9B3A-CF37B0944481}" type="datetimeFigureOut">
               <a:rPr lang="en-US" smtClean="0"/>
-              <a:t>4/24/25</a:t>
+              <a:t>6/6/25</a:t>
             </a:fld>
             <a:endParaRPr lang="en-US"/>
           </a:p>
@@ -1682,7 +1683,7 @@
           <a:p>
             <a:fld id="{00653A69-F55D-6944-9B3A-CF37B0944481}" type="datetimeFigureOut">
               <a:rPr lang="en-US" smtClean="0"/>
-              <a:t>4/24/25</a:t>
+              <a:t>6/6/25</a:t>
             </a:fld>
             <a:endParaRPr lang="en-US"/>
           </a:p>
@@ -2049,7 +2050,7 @@
           <a:p>
             <a:fld id="{00653A69-F55D-6944-9B3A-CF37B0944481}" type="datetimeFigureOut">
               <a:rPr lang="en-US" smtClean="0"/>
-              <a:t>4/24/25</a:t>
+              <a:t>6/6/25</a:t>
             </a:fld>
             <a:endParaRPr lang="en-US"/>
           </a:p>
@@ -2167,7 +2168,7 @@
           <a:p>
             <a:fld id="{00653A69-F55D-6944-9B3A-CF37B0944481}" type="datetimeFigureOut">
               <a:rPr lang="en-US" smtClean="0"/>
-              <a:t>4/24/25</a:t>
+              <a:t>6/6/25</a:t>
             </a:fld>
             <a:endParaRPr lang="en-US"/>
           </a:p>
@@ -2262,7 +2263,7 @@
           <a:p>
             <a:fld id="{00653A69-F55D-6944-9B3A-CF37B0944481}" type="datetimeFigureOut">
               <a:rPr lang="en-US" smtClean="0"/>
-              <a:t>4/24/25</a:t>
+              <a:t>6/6/25</a:t>
             </a:fld>
             <a:endParaRPr lang="en-US"/>
           </a:p>
@@ -2539,7 +2540,7 @@
           <a:p>
             <a:fld id="{00653A69-F55D-6944-9B3A-CF37B0944481}" type="datetimeFigureOut">
               <a:rPr lang="en-US" smtClean="0"/>
-              <a:t>4/24/25</a:t>
+              <a:t>6/6/25</a:t>
             </a:fld>
             <a:endParaRPr lang="en-US"/>
           </a:p>
@@ -2796,7 +2797,7 @@
           <a:p>
             <a:fld id="{00653A69-F55D-6944-9B3A-CF37B0944481}" type="datetimeFigureOut">
               <a:rPr lang="en-US" smtClean="0"/>
-              <a:t>4/24/25</a:t>
+              <a:t>6/6/25</a:t>
             </a:fld>
             <a:endParaRPr lang="en-US"/>
           </a:p>
@@ -3009,7 +3010,7 @@
           <a:p>
             <a:fld id="{00653A69-F55D-6944-9B3A-CF37B0944481}" type="datetimeFigureOut">
               <a:rPr lang="en-US" smtClean="0"/>
-              <a:t>4/24/25</a:t>
+              <a:t>6/6/25</a:t>
             </a:fld>
             <a:endParaRPr lang="en-US"/>
           </a:p>
@@ -4790,6 +4791,36 @@
     <p:extLst>
       <p:ext uri="{BB962C8B-B14F-4D97-AF65-F5344CB8AC3E}">
         <p14:creationId xmlns:p14="http://schemas.microsoft.com/office/powerpoint/2010/main" val="627171304"/>
+      </p:ext>
+    </p:extLst>
+  </p:cSld>
+  <p:clrMapOvr>
+    <a:masterClrMapping/>
+  </p:clrMapOvr>
+</p:sld>
+</file>
+
+<file path=ppt/slides/slide2.xml><?xml version="1.0" encoding="utf-8"?>
+<p:sld xmlns:a="http://schemas.openxmlformats.org/drawingml/2006/main" xmlns:r="http://schemas.openxmlformats.org/officeDocument/2006/relationships" xmlns:p="http://schemas.openxmlformats.org/presentationml/2006/main">
+  <p:cSld>
+    <p:spTree>
+      <p:nvGrpSpPr>
+        <p:cNvPr id="1" name=""/>
+        <p:cNvGrpSpPr/>
+        <p:nvPr/>
+      </p:nvGrpSpPr>
+      <p:grpSpPr>
+        <a:xfrm>
+          <a:off x="0" y="0"/>
+          <a:ext cx="0" cy="0"/>
+          <a:chOff x="0" y="0"/>
+          <a:chExt cx="0" cy="0"/>
+        </a:xfrm>
+      </p:grpSpPr>
+    </p:spTree>
+    <p:extLst>
+      <p:ext uri="{BB962C8B-B14F-4D97-AF65-F5344CB8AC3E}">
+        <p14:creationId xmlns:p14="http://schemas.microsoft.com/office/powerpoint/2010/main" val="1618595952"/>
       </p:ext>
     </p:extLst>
   </p:cSld>

</xml_diff>